<commit_message>
fix: gold logic - savings not stock KV, CSA/HCA fork, mHC facts
</commit_message>
<xml_diff>
--- a/eval/gold/optimized.pptx
+++ b/eval/gold/optimized.pptx
@@ -21,6 +21,7 @@
     <p:sldId id="263" r:id="rId20"/>
     <p:sldId id="264" r:id="rId21"/>
     <p:sldId id="265" r:id="rId22"/>
+    <p:sldId id="266" r:id="rId23"/>
   </p:sldIdLst>
   <p:sldSz cx="12192000" cy="6858000"/>
   <p:notesSz cx="6858000" cy="9144000"/>
@@ -28073,6 +28074,189 @@
             <a:spLocks noGrp="1"/>
           </p:cNvSpPr>
           <p:nvPr>
+            <p:ph type="body" idx="16" sz="quarter"/>
+          </p:nvPr>
+        </p:nvSpPr>
+        <p:spPr/>
+        <p:txBody>
+          <a:bodyPr/>
+          <a:lstStyle/>
+          <a:p>
+            <a:r>
+              <a:t>Gemma 4 E2B</a:t>
+            </a:r>
+          </a:p>
+          <a:p>
+            <a:pPr/>
+            <a:r>
+              <a:t>128K bf16</a:t>
+            </a:r>
+          </a:p>
+          <a:p>
+            <a:pPr/>
+            <a:r>
+              <a:t>跨層分享約省 2.7 GB</a:t>
+            </a:r>
+          </a:p>
+          <a:p>
+            <a:pPr/>
+            <a:r>
+              <a:t>（未計滑窗）</a:t>
+            </a:r>
+          </a:p>
+        </p:txBody>
+      </p:sp>
+      <p:sp>
+        <p:nvSpPr>
+          <p:cNvPr id="3" name="Text Placeholder 2"/>
+          <p:cNvSpPr>
+            <a:spLocks noGrp="1"/>
+          </p:cNvSpPr>
+          <p:nvPr>
+            <p:ph type="body" idx="47" sz="quarter"/>
+          </p:nvPr>
+        </p:nvSpPr>
+        <p:spPr/>
+        <p:txBody>
+          <a:bodyPr/>
+          <a:lstStyle/>
+          <a:p>
+            <a:r>
+              <a:t>Gemma 4 E4B</a:t>
+            </a:r>
+          </a:p>
+          <a:p>
+            <a:pPr/>
+            <a:r>
+              <a:t>128K</a:t>
+            </a:r>
+          </a:p>
+          <a:p>
+            <a:pPr/>
+            <a:r>
+              <a:t>跨層分享約省 6 GB</a:t>
+            </a:r>
+          </a:p>
+          <a:p>
+            <a:pPr/>
+            <a:r>
+              <a:t>（未計滑窗）</a:t>
+            </a:r>
+          </a:p>
+        </p:txBody>
+      </p:sp>
+      <p:sp>
+        <p:nvSpPr>
+          <p:cNvPr id="4" name="Text Placeholder 3"/>
+          <p:cNvSpPr>
+            <a:spLocks noGrp="1"/>
+          </p:cNvSpPr>
+          <p:nvPr>
+            <p:ph type="body" idx="48" sz="quarter"/>
+          </p:nvPr>
+        </p:nvSpPr>
+        <p:spPr/>
+        <p:txBody>
+          <a:bodyPr/>
+          <a:lstStyle/>
+          <a:p>
+            <a:r>
+              <a:t>V4-Pro @ 1M</a:t>
+            </a:r>
+          </a:p>
+          <a:p>
+            <a:pPr/>
+            <a:r>
+              <a:t>27% FLOPs</a:t>
+            </a:r>
+          </a:p>
+          <a:p>
+            <a:pPr/>
+            <a:r>
+              <a:t>10% KV vs V3.2</a:t>
+            </a:r>
+          </a:p>
+        </p:txBody>
+      </p:sp>
+      <p:sp>
+        <p:nvSpPr>
+          <p:cNvPr id="5" name="Text Placeholder 4"/>
+          <p:cNvSpPr>
+            <a:spLocks noGrp="1"/>
+          </p:cNvSpPr>
+          <p:nvPr>
+            <p:ph type="body" idx="49" sz="quarter"/>
+          </p:nvPr>
+        </p:nvSpPr>
+        <p:spPr/>
+        <p:txBody>
+          <a:bodyPr/>
+          <a:lstStyle/>
+          <a:p>
+            <a:r>
+              <a:t>V4-Flash @ 1M</a:t>
+            </a:r>
+          </a:p>
+          <a:p>
+            <a:pPr/>
+            <a:r>
+              <a:t>10% FLOPs</a:t>
+            </a:r>
+          </a:p>
+          <a:p>
+            <a:pPr/>
+            <a:r>
+              <a:t>7% KV vs V3.2</a:t>
+            </a:r>
+          </a:p>
+        </p:txBody>
+      </p:sp>
+      <p:sp>
+        <p:nvSpPr>
+          <p:cNvPr id="6" name="Title 5"/>
+          <p:cNvSpPr>
+            <a:spLocks noGrp="1"/>
+          </p:cNvSpPr>
+          <p:nvPr>
+            <p:ph type="title"/>
+          </p:nvPr>
+        </p:nvSpPr>
+        <p:spPr/>
+        <p:txBody>
+          <a:bodyPr/>
+          <a:lstStyle/>
+          <a:p>
+            <a:r>
+              <a:t>跨層分享省的是數 GB；V4 在 1M 把 KV 壓到 V3.2 的 7–10%</a:t>
+            </a:r>
+          </a:p>
+        </p:txBody>
+      </p:sp>
+    </p:spTree>
+  </p:cSld>
+  <p:clrMapOvr>
+    <a:masterClrMapping/>
+  </p:clrMapOvr>
+</p:sld>
+</file>
+
+<file path=ppt/slides/slide11.xml><?xml version="1.0" encoding="utf-8"?>
+<p:sld xmlns:a="http://schemas.openxmlformats.org/drawingml/2006/main" xmlns:p="http://schemas.openxmlformats.org/presentationml/2006/main" xmlns:r="http://schemas.openxmlformats.org/officeDocument/2006/relationships">
+  <p:cSld>
+    <p:spTree>
+      <p:nvGrpSpPr>
+        <p:cNvPr id="1" name=""/>
+        <p:cNvGrpSpPr/>
+        <p:nvPr/>
+      </p:nvGrpSpPr>
+      <p:grpSpPr/>
+      <p:sp>
+        <p:nvSpPr>
+          <p:cNvPr id="2" name="Text Placeholder 1"/>
+          <p:cNvSpPr>
+            <a:spLocks noGrp="1"/>
+          </p:cNvSpPr>
+          <p:nvPr>
             <p:ph type="body" idx="13" sz="quarter"/>
           </p:nvPr>
         </p:nvSpPr>
@@ -28232,7 +28416,7 @@
           <a:lstStyle/>
           <a:p>
             <a:r>
-              <a:t>新架構在砍三種成本：KV 記憶體、Attention FLOPs、Residual 表達力</a:t>
+              <a:t>新架構在砍三種平行成本，不是一條流水線</a:t>
             </a:r>
           </a:p>
         </p:txBody>
@@ -28393,16 +28577,335 @@
           </a:p>
         </p:txBody>
       </p:sp>
+    </p:spTree>
+  </p:cSld>
+  <p:clrMapOvr>
+    <a:masterClrMapping/>
+  </p:clrMapOvr>
+</p:sld>
+</file>
+
+<file path=ppt/slides/slide4.xml><?xml version="1.0" encoding="utf-8"?>
+<p:sld xmlns:a="http://schemas.openxmlformats.org/drawingml/2006/main" xmlns:p="http://schemas.openxmlformats.org/presentationml/2006/main" xmlns:r="http://schemas.openxmlformats.org/officeDocument/2006/relationships">
+  <p:cSld>
+    <p:spTree>
+      <p:nvGrpSpPr>
+        <p:cNvPr id="1" name=""/>
+        <p:cNvGrpSpPr/>
+        <p:nvPr/>
+      </p:nvGrpSpPr>
+      <p:grpSpPr/>
+      <p:sp>
+        <p:nvSpPr>
+          <p:cNvPr id="2" name="Title 1"/>
+          <p:cNvSpPr>
+            <a:spLocks noGrp="1"/>
+          </p:cNvSpPr>
+          <p:nvPr>
+            <p:ph type="title"/>
+          </p:nvPr>
+        </p:nvSpPr>
+        <p:spPr/>
+        <p:txBody>
+          <a:bodyPr/>
+          <a:lstStyle/>
+          <a:p>
+            <a:r>
+              <a:t>四種改動都掛在同一個 decoder block 上</a:t>
+            </a:r>
+          </a:p>
+        </p:txBody>
+      </p:sp>
+      <p:sp>
+        <p:nvSpPr>
+          <p:cNvPr id="3" name="Rounded Rectangle 2"/>
+          <p:cNvSpPr/>
+          <p:nvPr/>
+        </p:nvSpPr>
+        <p:spPr>
+          <a:xfrm>
+            <a:off x="3291840" y="2148840"/>
+            <a:ext cx="5486400" cy="1554480"/>
+          </a:xfrm>
+          <a:prstGeom prst="roundRect">
+            <a:avLst/>
+          </a:prstGeom>
+          <a:solidFill>
+            <a:srgbClr val="004479"/>
+          </a:solidFill>
+          <a:ln>
+            <a:noFill/>
+          </a:ln>
+        </p:spPr>
+        <p:style>
+          <a:lnRef idx="1">
+            <a:schemeClr val="accent1"/>
+          </a:lnRef>
+          <a:fillRef idx="3">
+            <a:schemeClr val="accent1"/>
+          </a:fillRef>
+          <a:effectRef idx="2">
+            <a:schemeClr val="accent1"/>
+          </a:effectRef>
+          <a:fontRef idx="minor">
+            <a:schemeClr val="lt1"/>
+          </a:fontRef>
+        </p:style>
+        <p:txBody>
+          <a:bodyPr rtlCol="0" anchor="ctr" wrap="square"/>
+          <a:lstStyle/>
+          <a:p>
+            <a:pPr algn="ctr">
+              <a:defRPr sz="1600" b="1">
+                <a:solidFill>
+                  <a:srgbClr val="FFFFFF"/>
+                </a:solidFill>
+              </a:defRPr>
+            </a:pPr>
+            <a:r>
+              <a:t>Decoder block</a:t>
+            </a:r>
+            <a:br/>
+            <a:r>
+              <a:t>Attention + FFN</a:t>
+            </a:r>
+          </a:p>
+        </p:txBody>
+      </p:sp>
+      <p:sp>
+        <p:nvSpPr>
+          <p:cNvPr id="4" name="Rounded Rectangle 3"/>
+          <p:cNvSpPr/>
+          <p:nvPr/>
+        </p:nvSpPr>
+        <p:spPr>
+          <a:xfrm>
+            <a:off x="411480" y="1691640"/>
+            <a:ext cx="2743200" cy="1051560"/>
+          </a:xfrm>
+          <a:prstGeom prst="roundRect">
+            <a:avLst/>
+          </a:prstGeom>
+          <a:solidFill>
+            <a:srgbClr val="000542"/>
+          </a:solidFill>
+          <a:ln>
+            <a:noFill/>
+          </a:ln>
+        </p:spPr>
+        <p:style>
+          <a:lnRef idx="1">
+            <a:schemeClr val="accent1"/>
+          </a:lnRef>
+          <a:fillRef idx="3">
+            <a:schemeClr val="accent1"/>
+          </a:fillRef>
+          <a:effectRef idx="2">
+            <a:schemeClr val="accent1"/>
+          </a:effectRef>
+          <a:fontRef idx="minor">
+            <a:schemeClr val="lt1"/>
+          </a:fontRef>
+        </p:style>
+        <p:txBody>
+          <a:bodyPr rtlCol="0" anchor="ctr" wrap="square"/>
+          <a:lstStyle/>
+          <a:p>
+            <a:pPr algn="ctr">
+              <a:defRPr sz="1200" b="1">
+                <a:solidFill>
+                  <a:srgbClr val="FFFFFF"/>
+                </a:solidFill>
+              </a:defRPr>
+            </a:pPr>
+            <a:r>
+              <a:t>KV-share</a:t>
+            </a:r>
+            <a:br/>
+            <a:r>
+              <a:t>跨層重用 K/V</a:t>
+            </a:r>
+          </a:p>
+        </p:txBody>
+      </p:sp>
+      <p:sp>
+        <p:nvSpPr>
+          <p:cNvPr id="5" name="Rounded Rectangle 4"/>
+          <p:cNvSpPr/>
+          <p:nvPr/>
+        </p:nvSpPr>
+        <p:spPr>
+          <a:xfrm>
+            <a:off x="8732520" y="1691640"/>
+            <a:ext cx="2743200" cy="1051560"/>
+          </a:xfrm>
+          <a:prstGeom prst="roundRect">
+            <a:avLst/>
+          </a:prstGeom>
+          <a:solidFill>
+            <a:srgbClr val="000542"/>
+          </a:solidFill>
+          <a:ln>
+            <a:noFill/>
+          </a:ln>
+        </p:spPr>
+        <p:style>
+          <a:lnRef idx="1">
+            <a:schemeClr val="accent1"/>
+          </a:lnRef>
+          <a:fillRef idx="3">
+            <a:schemeClr val="accent1"/>
+          </a:fillRef>
+          <a:effectRef idx="2">
+            <a:schemeClr val="accent1"/>
+          </a:effectRef>
+          <a:fontRef idx="minor">
+            <a:schemeClr val="lt1"/>
+          </a:fontRef>
+        </p:style>
+        <p:txBody>
+          <a:bodyPr rtlCol="0" anchor="ctr" wrap="square"/>
+          <a:lstStyle/>
+          <a:p>
+            <a:pPr algn="ctr">
+              <a:defRPr sz="1200" b="1">
+                <a:solidFill>
+                  <a:srgbClr val="FFFFFF"/>
+                </a:solidFill>
+              </a:defRPr>
+            </a:pPr>
+            <a:r>
+              <a:t>PLE</a:t>
+            </a:r>
+            <a:br/>
+            <a:r>
+              <a:t>lookup 補容量</a:t>
+            </a:r>
+          </a:p>
+        </p:txBody>
+      </p:sp>
+      <p:sp>
+        <p:nvSpPr>
+          <p:cNvPr id="6" name="Rounded Rectangle 5"/>
+          <p:cNvSpPr/>
+          <p:nvPr/>
+        </p:nvSpPr>
+        <p:spPr>
+          <a:xfrm>
+            <a:off x="411480" y="4160520"/>
+            <a:ext cx="2743200" cy="1051560"/>
+          </a:xfrm>
+          <a:prstGeom prst="roundRect">
+            <a:avLst/>
+          </a:prstGeom>
+          <a:solidFill>
+            <a:srgbClr val="000542"/>
+          </a:solidFill>
+          <a:ln>
+            <a:noFill/>
+          </a:ln>
+        </p:spPr>
+        <p:style>
+          <a:lnRef idx="1">
+            <a:schemeClr val="accent1"/>
+          </a:lnRef>
+          <a:fillRef idx="3">
+            <a:schemeClr val="accent1"/>
+          </a:fillRef>
+          <a:effectRef idx="2">
+            <a:schemeClr val="accent1"/>
+          </a:effectRef>
+          <a:fontRef idx="minor">
+            <a:schemeClr val="lt1"/>
+          </a:fontRef>
+        </p:style>
+        <p:txBody>
+          <a:bodyPr rtlCol="0" anchor="ctr" wrap="square"/>
+          <a:lstStyle/>
+          <a:p>
+            <a:pPr algn="ctr">
+              <a:defRPr sz="1200" b="1">
+                <a:solidFill>
+                  <a:srgbClr val="FFFFFF"/>
+                </a:solidFill>
+              </a:defRPr>
+            </a:pPr>
+            <a:r>
+              <a:t>CCA</a:t>
+            </a:r>
+            <a:br/>
+            <a:r>
+              <a:t>潛空間算 attention</a:t>
+            </a:r>
+          </a:p>
+        </p:txBody>
+      </p:sp>
+      <p:sp>
+        <p:nvSpPr>
+          <p:cNvPr id="7" name="Rounded Rectangle 6"/>
+          <p:cNvSpPr/>
+          <p:nvPr/>
+        </p:nvSpPr>
+        <p:spPr>
+          <a:xfrm>
+            <a:off x="8732520" y="4160520"/>
+            <a:ext cx="2743200" cy="1051560"/>
+          </a:xfrm>
+          <a:prstGeom prst="roundRect">
+            <a:avLst/>
+          </a:prstGeom>
+          <a:solidFill>
+            <a:srgbClr val="000542"/>
+          </a:solidFill>
+          <a:ln>
+            <a:noFill/>
+          </a:ln>
+        </p:spPr>
+        <p:style>
+          <a:lnRef idx="1">
+            <a:schemeClr val="accent1"/>
+          </a:lnRef>
+          <a:fillRef idx="3">
+            <a:schemeClr val="accent1"/>
+          </a:fillRef>
+          <a:effectRef idx="2">
+            <a:schemeClr val="accent1"/>
+          </a:effectRef>
+          <a:fontRef idx="minor">
+            <a:schemeClr val="lt1"/>
+          </a:fontRef>
+        </p:style>
+        <p:txBody>
+          <a:bodyPr rtlCol="0" anchor="ctr" wrap="square"/>
+          <a:lstStyle/>
+          <a:p>
+            <a:pPr algn="ctr">
+              <a:defRPr sz="1200" b="1">
+                <a:solidFill>
+                  <a:srgbClr val="FFFFFF"/>
+                </a:solidFill>
+              </a:defRPr>
+            </a:pPr>
+            <a:r>
+              <a:t>mHC</a:t>
+            </a:r>
+            <a:br/>
+            <a:r>
+              <a:t>n=4 residual</a:t>
+            </a:r>
+          </a:p>
+        </p:txBody>
+      </p:sp>
       <p:cxnSp>
         <p:nvCxnSpPr>
-          <p:cNvPr id="6" name="Connector 5"/>
+          <p:cNvPr id="8" name="Connector 7"/>
           <p:cNvCxnSpPr/>
           <p:nvPr/>
         </p:nvCxnSpPr>
         <p:spPr>
           <a:xfrm>
-            <a:off x="4053840" y="3406140"/>
-            <a:ext cx="228600" cy="0"/>
+            <a:off x="1783080" y="2217420"/>
+            <a:ext cx="4251960" cy="708660"/>
           </a:xfrm>
           <a:prstGeom prst="line">
             <a:avLst/>
@@ -28430,14 +28933,84 @@
       </p:cxnSp>
       <p:cxnSp>
         <p:nvCxnSpPr>
-          <p:cNvPr id="7" name="Connector 6"/>
+          <p:cNvPr id="9" name="Connector 8"/>
           <p:cNvCxnSpPr/>
           <p:nvPr/>
         </p:nvCxnSpPr>
         <p:spPr>
-          <a:xfrm>
-            <a:off x="7879080" y="3406140"/>
-            <a:ext cx="228600" cy="0"/>
+          <a:xfrm flipH="1">
+            <a:off x="6035040" y="2217420"/>
+            <a:ext cx="4069080" cy="708660"/>
+          </a:xfrm>
+          <a:prstGeom prst="line">
+            <a:avLst/>
+          </a:prstGeom>
+          <a:ln w="19050">
+            <a:solidFill>
+              <a:srgbClr val="111111"/>
+            </a:solidFill>
+          </a:ln>
+        </p:spPr>
+        <p:style>
+          <a:lnRef idx="2">
+            <a:schemeClr val="accent1"/>
+          </a:lnRef>
+          <a:fillRef idx="0">
+            <a:schemeClr val="accent1"/>
+          </a:fillRef>
+          <a:effectRef idx="1">
+            <a:schemeClr val="accent1"/>
+          </a:effectRef>
+          <a:fontRef idx="minor">
+            <a:schemeClr val="tx1"/>
+          </a:fontRef>
+        </p:style>
+      </p:cxnSp>
+      <p:cxnSp>
+        <p:nvCxnSpPr>
+          <p:cNvPr id="10" name="Connector 9"/>
+          <p:cNvCxnSpPr/>
+          <p:nvPr/>
+        </p:nvCxnSpPr>
+        <p:spPr>
+          <a:xfrm flipV="1">
+            <a:off x="1783080" y="2926080"/>
+            <a:ext cx="4251960" cy="1760220"/>
+          </a:xfrm>
+          <a:prstGeom prst="line">
+            <a:avLst/>
+          </a:prstGeom>
+          <a:ln w="19050">
+            <a:solidFill>
+              <a:srgbClr val="111111"/>
+            </a:solidFill>
+          </a:ln>
+        </p:spPr>
+        <p:style>
+          <a:lnRef idx="2">
+            <a:schemeClr val="accent1"/>
+          </a:lnRef>
+          <a:fillRef idx="0">
+            <a:schemeClr val="accent1"/>
+          </a:fillRef>
+          <a:effectRef idx="1">
+            <a:schemeClr val="accent1"/>
+          </a:effectRef>
+          <a:fontRef idx="minor">
+            <a:schemeClr val="tx1"/>
+          </a:fontRef>
+        </p:style>
+      </p:cxnSp>
+      <p:cxnSp>
+        <p:nvCxnSpPr>
+          <p:cNvPr id="11" name="Connector 10"/>
+          <p:cNvCxnSpPr/>
+          <p:nvPr/>
+        </p:nvCxnSpPr>
+        <p:spPr>
+          <a:xfrm flipH="1" flipV="1">
+            <a:off x="6035040" y="2926080"/>
+            <a:ext cx="4069080" cy="1760220"/>
           </a:xfrm>
           <a:prstGeom prst="line">
             <a:avLst/>
@@ -28471,117 +29044,6 @@
 </p:sld>
 </file>
 
-<file path=ppt/slides/slide4.xml><?xml version="1.0" encoding="utf-8"?>
-<p:sld xmlns:a="http://schemas.openxmlformats.org/drawingml/2006/main" xmlns:p="http://schemas.openxmlformats.org/presentationml/2006/main" xmlns:r="http://schemas.openxmlformats.org/officeDocument/2006/relationships">
-  <p:cSld>
-    <p:spTree>
-      <p:nvGrpSpPr>
-        <p:cNvPr id="1" name=""/>
-        <p:cNvGrpSpPr/>
-        <p:nvPr/>
-      </p:nvGrpSpPr>
-      <p:grpSpPr/>
-      <p:sp>
-        <p:nvSpPr>
-          <p:cNvPr id="2" name="Title 1"/>
-          <p:cNvSpPr>
-            <a:spLocks noGrp="1"/>
-          </p:cNvSpPr>
-          <p:nvPr>
-            <p:ph type="title"/>
-          </p:nvPr>
-        </p:nvSpPr>
-        <p:spPr/>
-        <p:txBody>
-          <a:bodyPr/>
-          <a:lstStyle/>
-          <a:p>
-            <a:r>
-              <a:t>Gemma 4 用跨層 KV 重用砍 cache，把多出來的容量放進 PLE</a:t>
-            </a:r>
-          </a:p>
-        </p:txBody>
-      </p:sp>
-      <p:sp>
-        <p:nvSpPr>
-          <p:cNvPr id="3" name="Text Placeholder 2"/>
-          <p:cNvSpPr>
-            <a:spLocks noGrp="1"/>
-          </p:cNvSpPr>
-          <p:nvPr>
-            <p:ph type="body" idx="15" sz="quarter"/>
-          </p:nvPr>
-        </p:nvSpPr>
-        <p:spPr/>
-        <p:txBody>
-          <a:bodyPr/>
-          <a:lstStyle/>
-          <a:p>
-            <a:r>
-              <a:t>E2B：35 層，前 15 算 KV，後 20 重用；MQA + 滑窗 4:1</a:t>
-            </a:r>
-          </a:p>
-          <a:p>
-            <a:pPr/>
-            <a:r>
-              <a:t>E4B：42 層，24 算 KV，後 18 重用</a:t>
-            </a:r>
-          </a:p>
-          <a:p>
-            <a:pPr/>
-            <a:r>
-              <a:t>128K bf16：E2B 約省 2.7 GB，E4B 約 6 GB（未計滑窗）</a:t>
-            </a:r>
-          </a:p>
-        </p:txBody>
-      </p:sp>
-      <p:sp>
-        <p:nvSpPr>
-          <p:cNvPr id="4" name="Text Placeholder 3"/>
-          <p:cNvSpPr>
-            <a:spLocks noGrp="1"/>
-          </p:cNvSpPr>
-          <p:nvPr>
-            <p:ph type="body" idx="16" sz="quarter"/>
-          </p:nvPr>
-        </p:nvSpPr>
-        <p:spPr/>
-        <p:txBody>
-          <a:bodyPr/>
-          <a:lstStyle/>
-          <a:p>
-            <a:r>
-              <a:t>PLE：E2B 2.3B effective / 5.1B with embeddings</a:t>
-            </a:r>
-          </a:p>
-          <a:p>
-            <a:pPr/>
-            <a:r>
-              <a:t>E4B 4.5B / 8B</a:t>
-            </a:r>
-          </a:p>
-          <a:p>
-            <a:pPr/>
-            <a:r>
-              <a:t>額外容量在 lookup 表，不把整個 stack 做胖</a:t>
-            </a:r>
-          </a:p>
-          <a:p>
-            <a:pPr/>
-            <a:r>
-              <a:t>作者承認缺少對 2.3B / 5.1B 常規模型的公開對照</a:t>
-            </a:r>
-          </a:p>
-        </p:txBody>
-      </p:sp>
-    </p:spTree>
-  </p:cSld>
-  <p:clrMapOvr>
-    <a:masterClrMapping/>
-  </p:clrMapOvr>
-</p:sld>
-</file>
-
 <file path=ppt/slides/slide5.xml><?xml version="1.0" encoding="utf-8"?>
 <p:sld xmlns:a="http://schemas.openxmlformats.org/drawingml/2006/main" xmlns:p="http://schemas.openxmlformats.org/presentationml/2006/main" xmlns:r="http://schemas.openxmlformats.org/officeDocument/2006/relationships">
   <p:cSld>
@@ -28608,7 +29070,7 @@
           <a:lstStyle/>
           <a:p>
             <a:r>
-              <a:t>Laguna 把 query head 花在便宜的區域層，克扣昂貴的全域層</a:t>
+              <a:t>Gemma 4 用跨層 KV 重用砍 cache，把多出來的容量放進 PLE</a:t>
             </a:r>
           </a:p>
         </p:txBody>
@@ -28629,19 +29091,25 @@
           <a:lstStyle/>
           <a:p>
             <a:r>
-              <a:t>40 層：30 滑窗（512）+ 10 全域</a:t>
+              <a:t>家族還有 26B MoE 與 31B dense；E2B/E4B 才做跨層 KV 分享</a:t>
             </a:r>
           </a:p>
           <a:p>
             <a:pPr/>
             <a:r>
-              <a:t>KV head 固定 8</a:t>
+              <a:t>E2B：35 層，前 15 算 KV，後 20 重用；MQA + 滑窗 4:1</a:t>
             </a:r>
           </a:p>
           <a:p>
             <a:pPr/>
             <a:r>
-              <a:t>全域層 6 query / KV；滑窗層 8 query / KV</a:t>
+              <a:t>E4B：42 層，24 算 KV，後 18 重用</a:t>
+            </a:r>
+          </a:p>
+          <a:p>
+            <a:pPr/>
+            <a:r>
+              <a:t>128K bf16：E2B 約省 2.7 GB，E4B 約省 6 GB（未計滑窗）</a:t>
             </a:r>
           </a:p>
         </p:txBody>
@@ -28662,19 +29130,25 @@
           <a:lstStyle/>
           <a:p>
             <a:r>
-              <a:t>混滑窗+全域並非新發明（Gemma 4 也用）</a:t>
+              <a:t>PLE：E2B 2.3B effective / 5.1B with embeddings</a:t>
             </a:r>
           </a:p>
           <a:p>
             <a:pPr/>
             <a:r>
-              <a:t>新的是 per-layer query-head 預算</a:t>
+              <a:t>E4B 4.5B / 8B</a:t>
             </a:r>
           </a:p>
           <a:p>
             <a:pPr/>
             <a:r>
-              <a:t>先例：Apple OpenELM 2024</a:t>
+              <a:t>額外容量在 lookup 表，不把整個 stack 做胖</a:t>
+            </a:r>
+          </a:p>
+          <a:p>
+            <a:pPr/>
+            <a:r>
+              <a:t>作者承認缺少對 2.3B / 5.1B 常規模型的公開對照</a:t>
             </a:r>
           </a:p>
         </p:txBody>
@@ -28713,7 +29187,7 @@
           <a:lstStyle/>
           <a:p>
             <a:r>
-              <a:t>ZAYA1 在壓縮潛空間裡做 attention，不是只壓縮 KV cache</a:t>
+              <a:t>Laguna 把 query head 花在便宜的區域層，克扣昂貴的全域層</a:t>
             </a:r>
           </a:p>
         </p:txBody>
@@ -28734,19 +29208,19 @@
           <a:lstStyle/>
           <a:p>
             <a:r>
-              <a:t>MLA：壓縮 KV 再投影回 head 空間才算 attention</a:t>
+              <a:t>40 層：30 滑窗（512）+ 10 全域</a:t>
             </a:r>
           </a:p>
           <a:p>
             <a:pPr/>
             <a:r>
-              <a:t>CCA：Q/K/V 都壓縮，attention 直接在潛空間算完再上投影</a:t>
+              <a:t>KV head 固定 8</a:t>
             </a:r>
           </a:p>
           <a:p>
             <a:pPr/>
             <a:r>
-              <a:t>省 cache 也省 prefill/training FLOPs</a:t>
+              <a:t>全域層 6 query / KV；滑窗層 8 query / KV</a:t>
             </a:r>
           </a:p>
         </p:txBody>
@@ -28767,19 +29241,19 @@
           <a:lstStyle/>
           <a:p>
             <a:r>
-              <a:t>壓縮後對 Q/K（不是 V）做卷積，補回區域上下文</a:t>
+              <a:t>混滑窗+全域並非新發明（Gemma 4 也用）</a:t>
             </a:r>
           </a:p>
           <a:p>
             <a:pPr/>
             <a:r>
-              <a:t>4:1 GQA；每 token 只啟動 1 個 routed expert</a:t>
+              <a:t>新的是 per-layer query-head 預算</a:t>
             </a:r>
           </a:p>
           <a:p>
             <a:pPr/>
             <a:r>
-              <a:t>CCA 論文自報優於 MLA——不是第三方 bake-off</a:t>
+              <a:t>先例：Apple OpenELM 2024</a:t>
             </a:r>
           </a:p>
         </p:txBody>
@@ -28818,7 +29292,7 @@
           <a:lstStyle/>
           <a:p>
             <a:r>
-              <a:t>DeepSeek V4 沿序列軸壓縮（CSA/HCA），並用 mHC 加寬 residual</a:t>
+              <a:t>ZAYA1 在壓縮潛空間裡做 attention，不是只壓縮 KV cache</a:t>
             </a:r>
           </a:p>
         </p:txBody>
@@ -28839,19 +29313,19 @@
           <a:lstStyle/>
           <a:p>
             <a:r>
-              <a:t>CSA：m=4 + 稀疏 top-k（DSA 風格）</a:t>
+              <a:t>MLA：壓縮 KV 再投影回 head 空間才算 attention</a:t>
             </a:r>
           </a:p>
           <a:p>
             <a:pPr/>
             <a:r>
-              <a:t>HCA：m'=128 再對短 cache 做 dense attention</a:t>
+              <a:t>CCA：Q/K/V 都壓縮，attention 直接在潛空間算完再上投影</a:t>
             </a:r>
           </a:p>
           <a:p>
             <a:pPr/>
             <a:r>
-              <a:t>兩者都保留 128 token 未壓縮近窗</a:t>
+              <a:t>省 cache 也省 prefill/training FLOPs</a:t>
             </a:r>
           </a:p>
         </p:txBody>
@@ -28872,25 +29346,19 @@
           <a:lstStyle/>
           <a:p>
             <a:r>
-              <a:t>相對 V3.2、1M context：</a:t>
+              <a:t>壓縮後對 Q/K（不是 V）做卷積，補回區域上下文</a:t>
             </a:r>
           </a:p>
           <a:p>
             <a:pPr/>
             <a:r>
-              <a:t>V4-Pro 27% FLOPs / 10% KV</a:t>
+              <a:t>4:1 GQA；每 token 只啟動 1 個 routed expert</a:t>
             </a:r>
           </a:p>
           <a:p>
             <a:pPr/>
             <a:r>
-              <a:t>V4-Flash 10% FLOPs / 7% KV</a:t>
-            </a:r>
-          </a:p>
-          <a:p>
-            <a:pPr/>
-            <a:r>
-              <a:t>作者：不能說 CSA/HCA 普遍優於 MLA；沒有獨立 ablation</a:t>
+              <a:t>CCA 論文自報優於 MLA——不是第三方 bake-off</a:t>
             </a:r>
           </a:p>
         </p:txBody>
@@ -28929,163 +29397,79 @@
           <a:lstStyle/>
           <a:p>
             <a:r>
-              <a:t>CSA 保細節、HCA 保覆蓋，近窗負責最新 token</a:t>
-            </a:r>
-          </a:p>
-        </p:txBody>
-      </p:sp>
-      <p:sp>
-        <p:nvSpPr>
-          <p:cNvPr id="3" name="Rounded Rectangle 2"/>
-          <p:cNvSpPr/>
-          <p:nvPr/>
-        </p:nvSpPr>
-        <p:spPr>
-          <a:xfrm>
-            <a:off x="1097280" y="2194560"/>
-            <a:ext cx="9601200" cy="777240"/>
-          </a:xfrm>
-          <a:prstGeom prst="roundRect">
-            <a:avLst/>
-          </a:prstGeom>
-          <a:solidFill>
-            <a:srgbClr val="004479"/>
-          </a:solidFill>
-          <a:ln>
-            <a:noFill/>
-          </a:ln>
-        </p:spPr>
-        <p:style>
-          <a:lnRef idx="1">
-            <a:schemeClr val="accent1"/>
-          </a:lnRef>
-          <a:fillRef idx="3">
-            <a:schemeClr val="accent1"/>
-          </a:fillRef>
-          <a:effectRef idx="2">
-            <a:schemeClr val="accent1"/>
-          </a:effectRef>
-          <a:fontRef idx="minor">
-            <a:schemeClr val="lt1"/>
-          </a:fontRef>
-        </p:style>
-        <p:txBody>
-          <a:bodyPr rtlCol="0" anchor="ctr" wrap="square"/>
+              <a:t>DeepSeek V4 沿序列軸壓縮（CSA/HCA），並用 mHC 加寬 residual</a:t>
+            </a:r>
+          </a:p>
+        </p:txBody>
+      </p:sp>
+      <p:sp>
+        <p:nvSpPr>
+          <p:cNvPr id="3" name="Text Placeholder 2"/>
+          <p:cNvSpPr>
+            <a:spLocks noGrp="1"/>
+          </p:cNvSpPr>
+          <p:nvPr>
+            <p:ph type="body" idx="15" sz="quarter"/>
+          </p:nvPr>
+        </p:nvSpPr>
+        <p:spPr/>
+        <p:txBody>
+          <a:bodyPr/>
           <a:lstStyle/>
           <a:p>
-            <a:pPr algn="ctr">
-              <a:defRPr sz="1400" b="1">
-                <a:solidFill>
-                  <a:srgbClr val="FFFFFF"/>
-                </a:solidFill>
-              </a:defRPr>
-            </a:pPr>
-            <a:r>
-              <a:t>近窗 128 token 未壓縮 KV</a:t>
-            </a:r>
-          </a:p>
-        </p:txBody>
-      </p:sp>
-      <p:sp>
-        <p:nvSpPr>
-          <p:cNvPr id="4" name="Rounded Rectangle 3"/>
-          <p:cNvSpPr/>
-          <p:nvPr/>
-        </p:nvSpPr>
-        <p:spPr>
-          <a:xfrm>
-            <a:off x="1097280" y="3136392"/>
-            <a:ext cx="9601200" cy="777240"/>
-          </a:xfrm>
-          <a:prstGeom prst="roundRect">
-            <a:avLst/>
-          </a:prstGeom>
-          <a:solidFill>
-            <a:srgbClr val="000542"/>
-          </a:solidFill>
-          <a:ln>
-            <a:noFill/>
-          </a:ln>
-        </p:spPr>
-        <p:style>
-          <a:lnRef idx="1">
-            <a:schemeClr val="accent1"/>
-          </a:lnRef>
-          <a:fillRef idx="3">
-            <a:schemeClr val="accent1"/>
-          </a:fillRef>
-          <a:effectRef idx="2">
-            <a:schemeClr val="accent1"/>
-          </a:effectRef>
-          <a:fontRef idx="minor">
-            <a:schemeClr val="lt1"/>
-          </a:fontRef>
-        </p:style>
-        <p:txBody>
-          <a:bodyPr rtlCol="0" anchor="ctr" wrap="square"/>
+            <a:r>
+              <a:t>CSA：m=4 + 稀疏 top-k（DSA 風格）</a:t>
+            </a:r>
+          </a:p>
+          <a:p>
+            <a:pPr/>
+            <a:r>
+              <a:t>HCA：m'=128 再對短 cache 做 dense attention</a:t>
+            </a:r>
+          </a:p>
+          <a:p>
+            <a:pPr/>
+            <a:r>
+              <a:t>兩者都保留 128 token 未壓縮近窗</a:t>
+            </a:r>
+          </a:p>
+        </p:txBody>
+      </p:sp>
+      <p:sp>
+        <p:nvSpPr>
+          <p:cNvPr id="4" name="Text Placeholder 3"/>
+          <p:cNvSpPr>
+            <a:spLocks noGrp="1"/>
+          </p:cNvSpPr>
+          <p:nvPr>
+            <p:ph type="body" idx="16" sz="quarter"/>
+          </p:nvPr>
+        </p:nvSpPr>
+        <p:spPr/>
+        <p:txBody>
+          <a:bodyPr/>
           <a:lstStyle/>
           <a:p>
-            <a:pPr algn="ctr">
-              <a:defRPr sz="1400" b="1">
-                <a:solidFill>
-                  <a:srgbClr val="FFFFFF"/>
-                </a:solidFill>
-              </a:defRPr>
-            </a:pPr>
-            <a:r>
-              <a:t>CSA m=4 稀疏選擇</a:t>
-            </a:r>
-          </a:p>
-        </p:txBody>
-      </p:sp>
-      <p:sp>
-        <p:nvSpPr>
-          <p:cNvPr id="5" name="Rounded Rectangle 4"/>
-          <p:cNvSpPr/>
-          <p:nvPr/>
-        </p:nvSpPr>
-        <p:spPr>
-          <a:xfrm>
-            <a:off x="1097280" y="4078224"/>
-            <a:ext cx="9601200" cy="777240"/>
-          </a:xfrm>
-          <a:prstGeom prst="roundRect">
-            <a:avLst/>
-          </a:prstGeom>
-          <a:solidFill>
-            <a:srgbClr val="5E5E5E"/>
-          </a:solidFill>
-          <a:ln>
-            <a:noFill/>
-          </a:ln>
-        </p:spPr>
-        <p:style>
-          <a:lnRef idx="1">
-            <a:schemeClr val="accent1"/>
-          </a:lnRef>
-          <a:fillRef idx="3">
-            <a:schemeClr val="accent1"/>
-          </a:fillRef>
-          <a:effectRef idx="2">
-            <a:schemeClr val="accent1"/>
-          </a:effectRef>
-          <a:fontRef idx="minor">
-            <a:schemeClr val="lt1"/>
-          </a:fontRef>
-        </p:style>
-        <p:txBody>
-          <a:bodyPr rtlCol="0" anchor="ctr" wrap="square"/>
-          <a:lstStyle/>
-          <a:p>
-            <a:pPr algn="ctr">
-              <a:defRPr sz="1400" b="1">
-                <a:solidFill>
-                  <a:srgbClr val="FFFFFF"/>
-                </a:solidFill>
-              </a:defRPr>
-            </a:pPr>
-            <a:r>
-              <a:t>HCA m'=128 dense 短 cache</a:t>
+            <a:r>
+              <a:t>mHC：n=4 平行 residual；Res mapping 投影到雙隨機矩陣</a:t>
+            </a:r>
+          </a:p>
+          <a:p>
+            <a:pPr/>
+            <a:r>
+              <a:t>27B 實作 n=4 訓練時間 +6.7%；原 HC FLOPs 13.36G→13.38G/token</a:t>
+            </a:r>
+          </a:p>
+          <a:p>
+            <a:pPr/>
+            <a:r>
+              <a:t>相對 V3.2、1M：V4-Pro 27% FLOPs / 10% KV；V4-Flash 10% / 7%</a:t>
+            </a:r>
+          </a:p>
+          <a:p>
+            <a:pPr/>
+            <a:r>
+              <a:t>作者：不能說 CSA/HCA 普遍優於 MLA；沒有獨立 ablation</a:t>
             </a:r>
           </a:p>
         </p:txBody>
@@ -29110,12 +29494,12 @@
       <p:grpSpPr/>
       <p:sp>
         <p:nvSpPr>
-          <p:cNvPr id="2" name="Text Placeholder 1"/>
-          <p:cNvSpPr>
-            <a:spLocks noGrp="1"/>
-          </p:cNvSpPr>
-          <p:nvPr>
-            <p:ph type="body" idx="16" sz="quarter"/>
+          <p:cNvPr id="2" name="Title 1"/>
+          <p:cNvSpPr>
+            <a:spLocks noGrp="1"/>
+          </p:cNvSpPr>
+          <p:nvPr>
+            <p:ph type="title"/>
           </p:nvPr>
         </p:nvSpPr>
         <p:spPr/>
@@ -29124,149 +29508,245 @@
           <a:lstStyle/>
           <a:p>
             <a:r>
-              <a:t>Gemma 4 E2B</a:t>
-            </a:r>
-          </a:p>
-          <a:p>
-            <a:pPr/>
-            <a:r>
-              <a:t>128K bf16</a:t>
-            </a:r>
-          </a:p>
-          <a:p>
-            <a:pPr/>
-            <a:r>
-              <a:t>約 2.7 GB KV</a:t>
-            </a:r>
-          </a:p>
-          <a:p>
-            <a:pPr/>
-            <a:r>
-              <a:t>（跨層分享、未計滑窗）</a:t>
-            </a:r>
-          </a:p>
-        </p:txBody>
-      </p:sp>
-      <p:sp>
-        <p:nvSpPr>
-          <p:cNvPr id="3" name="Text Placeholder 2"/>
-          <p:cNvSpPr>
-            <a:spLocks noGrp="1"/>
-          </p:cNvSpPr>
-          <p:nvPr>
-            <p:ph type="body" idx="47" sz="quarter"/>
-          </p:nvPr>
-        </p:nvSpPr>
-        <p:spPr/>
-        <p:txBody>
-          <a:bodyPr/>
+              <a:t>CSA 保細節、HCA 保覆蓋，近窗被兩條路徑共用</a:t>
+            </a:r>
+          </a:p>
+        </p:txBody>
+      </p:sp>
+      <p:sp>
+        <p:nvSpPr>
+          <p:cNvPr id="3" name="Rounded Rectangle 2"/>
+          <p:cNvSpPr/>
+          <p:nvPr/>
+        </p:nvSpPr>
+        <p:spPr>
+          <a:xfrm>
+            <a:off x="3108960" y="1965960"/>
+            <a:ext cx="5943600" cy="868680"/>
+          </a:xfrm>
+          <a:prstGeom prst="roundRect">
+            <a:avLst/>
+          </a:prstGeom>
+          <a:solidFill>
+            <a:srgbClr val="004479"/>
+          </a:solidFill>
+          <a:ln>
+            <a:noFill/>
+          </a:ln>
+        </p:spPr>
+        <p:style>
+          <a:lnRef idx="1">
+            <a:schemeClr val="accent1"/>
+          </a:lnRef>
+          <a:fillRef idx="3">
+            <a:schemeClr val="accent1"/>
+          </a:fillRef>
+          <a:effectRef idx="2">
+            <a:schemeClr val="accent1"/>
+          </a:effectRef>
+          <a:fontRef idx="minor">
+            <a:schemeClr val="lt1"/>
+          </a:fontRef>
+        </p:style>
+        <p:txBody>
+          <a:bodyPr rtlCol="0" anchor="ctr" wrap="square"/>
           <a:lstStyle/>
           <a:p>
-            <a:r>
-              <a:t>Gemma 4 E4B</a:t>
-            </a:r>
-          </a:p>
-          <a:p>
-            <a:pPr/>
-            <a:r>
-              <a:t>128K</a:t>
-            </a:r>
-          </a:p>
-          <a:p>
-            <a:pPr/>
-            <a:r>
-              <a:t>約 6 GB KV</a:t>
-            </a:r>
-          </a:p>
-        </p:txBody>
-      </p:sp>
-      <p:sp>
-        <p:nvSpPr>
-          <p:cNvPr id="4" name="Text Placeholder 3"/>
-          <p:cNvSpPr>
-            <a:spLocks noGrp="1"/>
-          </p:cNvSpPr>
-          <p:nvPr>
-            <p:ph type="body" idx="48" sz="quarter"/>
-          </p:nvPr>
-        </p:nvSpPr>
-        <p:spPr/>
-        <p:txBody>
-          <a:bodyPr/>
+            <a:pPr algn="ctr">
+              <a:defRPr sz="1300" b="1">
+                <a:solidFill>
+                  <a:srgbClr val="FFFFFF"/>
+                </a:solidFill>
+              </a:defRPr>
+            </a:pPr>
+            <a:r>
+              <a:t>近窗 128 token 未壓縮 KV（兩條路徑都保留）</a:t>
+            </a:r>
+          </a:p>
+        </p:txBody>
+      </p:sp>
+      <p:sp>
+        <p:nvSpPr>
+          <p:cNvPr id="4" name="Rounded Rectangle 3"/>
+          <p:cNvSpPr/>
+          <p:nvPr/>
+        </p:nvSpPr>
+        <p:spPr>
+          <a:xfrm>
+            <a:off x="640080" y="3794760"/>
+            <a:ext cx="5029200" cy="1097280"/>
+          </a:xfrm>
+          <a:prstGeom prst="roundRect">
+            <a:avLst/>
+          </a:prstGeom>
+          <a:solidFill>
+            <a:srgbClr val="000542"/>
+          </a:solidFill>
+          <a:ln>
+            <a:noFill/>
+          </a:ln>
+        </p:spPr>
+        <p:style>
+          <a:lnRef idx="1">
+            <a:schemeClr val="accent1"/>
+          </a:lnRef>
+          <a:fillRef idx="3">
+            <a:schemeClr val="accent1"/>
+          </a:fillRef>
+          <a:effectRef idx="2">
+            <a:schemeClr val="accent1"/>
+          </a:effectRef>
+          <a:fontRef idx="minor">
+            <a:schemeClr val="lt1"/>
+          </a:fontRef>
+        </p:style>
+        <p:txBody>
+          <a:bodyPr rtlCol="0" anchor="ctr" wrap="square"/>
           <a:lstStyle/>
           <a:p>
-            <a:r>
-              <a:t>V4-Pro @ 1M</a:t>
-            </a:r>
-          </a:p>
-          <a:p>
-            <a:pPr/>
-            <a:r>
-              <a:t>27% FLOPs</a:t>
-            </a:r>
-          </a:p>
-          <a:p>
-            <a:pPr/>
-            <a:r>
-              <a:t>10% KV vs V3.2</a:t>
-            </a:r>
-          </a:p>
-        </p:txBody>
-      </p:sp>
-      <p:sp>
-        <p:nvSpPr>
-          <p:cNvPr id="5" name="Text Placeholder 4"/>
-          <p:cNvSpPr>
-            <a:spLocks noGrp="1"/>
-          </p:cNvSpPr>
-          <p:nvPr>
-            <p:ph type="body" idx="49" sz="quarter"/>
-          </p:nvPr>
-        </p:nvSpPr>
-        <p:spPr/>
-        <p:txBody>
-          <a:bodyPr/>
+            <a:pPr algn="ctr">
+              <a:defRPr sz="1300" b="1">
+                <a:solidFill>
+                  <a:srgbClr val="FFFFFF"/>
+                </a:solidFill>
+              </a:defRPr>
+            </a:pPr>
+            <a:r>
+              <a:t>CSA：m=4 + 稀疏 top-k</a:t>
+            </a:r>
+            <a:br/>
+            <a:r>
+              <a:t>保細節</a:t>
+            </a:r>
+          </a:p>
+        </p:txBody>
+      </p:sp>
+      <p:sp>
+        <p:nvSpPr>
+          <p:cNvPr id="5" name="Rounded Rectangle 4"/>
+          <p:cNvSpPr/>
+          <p:nvPr/>
+        </p:nvSpPr>
+        <p:spPr>
+          <a:xfrm>
+            <a:off x="6492240" y="3794760"/>
+            <a:ext cx="5029200" cy="1097280"/>
+          </a:xfrm>
+          <a:prstGeom prst="roundRect">
+            <a:avLst/>
+          </a:prstGeom>
+          <a:solidFill>
+            <a:srgbClr val="5E5E5E"/>
+          </a:solidFill>
+          <a:ln>
+            <a:noFill/>
+          </a:ln>
+        </p:spPr>
+        <p:style>
+          <a:lnRef idx="1">
+            <a:schemeClr val="accent1"/>
+          </a:lnRef>
+          <a:fillRef idx="3">
+            <a:schemeClr val="accent1"/>
+          </a:fillRef>
+          <a:effectRef idx="2">
+            <a:schemeClr val="accent1"/>
+          </a:effectRef>
+          <a:fontRef idx="minor">
+            <a:schemeClr val="lt1"/>
+          </a:fontRef>
+        </p:style>
+        <p:txBody>
+          <a:bodyPr rtlCol="0" anchor="ctr" wrap="square"/>
           <a:lstStyle/>
           <a:p>
-            <a:r>
-              <a:t>V4-Flash @ 1M</a:t>
-            </a:r>
-          </a:p>
-          <a:p>
-            <a:pPr/>
-            <a:r>
-              <a:t>10% FLOPs</a:t>
-            </a:r>
-          </a:p>
-          <a:p>
-            <a:pPr/>
-            <a:r>
-              <a:t>7% KV vs V3.2</a:t>
-            </a:r>
-          </a:p>
-        </p:txBody>
-      </p:sp>
-      <p:sp>
-        <p:nvSpPr>
-          <p:cNvPr id="6" name="Title 5"/>
-          <p:cNvSpPr>
-            <a:spLocks noGrp="1"/>
-          </p:cNvSpPr>
-          <p:nvPr>
-            <p:ph type="title"/>
-          </p:nvPr>
-        </p:nvSpPr>
-        <p:spPr/>
-        <p:txBody>
-          <a:bodyPr/>
-          <a:lstStyle/>
-          <a:p>
-            <a:r>
-              <a:t>可核對的數字都在這張表，沒寫進來源的數字不要編</a:t>
-            </a:r>
-          </a:p>
-        </p:txBody>
-      </p:sp>
+            <a:pPr algn="ctr">
+              <a:defRPr sz="1300" b="1">
+                <a:solidFill>
+                  <a:srgbClr val="FFFFFF"/>
+                </a:solidFill>
+              </a:defRPr>
+            </a:pPr>
+            <a:r>
+              <a:t>HCA：m'=128 再 dense</a:t>
+            </a:r>
+            <a:br/>
+            <a:r>
+              <a:t>保覆蓋</a:t>
+            </a:r>
+          </a:p>
+        </p:txBody>
+      </p:sp>
+      <p:cxnSp>
+        <p:nvCxnSpPr>
+          <p:cNvPr id="6" name="Connector 5"/>
+          <p:cNvCxnSpPr/>
+          <p:nvPr/>
+        </p:nvCxnSpPr>
+        <p:spPr>
+          <a:xfrm flipH="1">
+            <a:off x="3154680" y="2834640"/>
+            <a:ext cx="2926080" cy="960120"/>
+          </a:xfrm>
+          <a:prstGeom prst="line">
+            <a:avLst/>
+          </a:prstGeom>
+          <a:ln w="19050">
+            <a:solidFill>
+              <a:srgbClr val="111111"/>
+            </a:solidFill>
+          </a:ln>
+        </p:spPr>
+        <p:style>
+          <a:lnRef idx="2">
+            <a:schemeClr val="accent1"/>
+          </a:lnRef>
+          <a:fillRef idx="0">
+            <a:schemeClr val="accent1"/>
+          </a:fillRef>
+          <a:effectRef idx="1">
+            <a:schemeClr val="accent1"/>
+          </a:effectRef>
+          <a:fontRef idx="minor">
+            <a:schemeClr val="tx1"/>
+          </a:fontRef>
+        </p:style>
+      </p:cxnSp>
+      <p:cxnSp>
+        <p:nvCxnSpPr>
+          <p:cNvPr id="7" name="Connector 6"/>
+          <p:cNvCxnSpPr/>
+          <p:nvPr/>
+        </p:nvCxnSpPr>
+        <p:spPr>
+          <a:xfrm>
+            <a:off x="6080760" y="2834640"/>
+            <a:ext cx="2926080" cy="960120"/>
+          </a:xfrm>
+          <a:prstGeom prst="line">
+            <a:avLst/>
+          </a:prstGeom>
+          <a:ln w="19050">
+            <a:solidFill>
+              <a:srgbClr val="111111"/>
+            </a:solidFill>
+          </a:ln>
+        </p:spPr>
+        <p:style>
+          <a:lnRef idx="2">
+            <a:schemeClr val="accent1"/>
+          </a:lnRef>
+          <a:fillRef idx="0">
+            <a:schemeClr val="accent1"/>
+          </a:fillRef>
+          <a:effectRef idx="1">
+            <a:schemeClr val="accent1"/>
+          </a:effectRef>
+          <a:fontRef idx="minor">
+            <a:schemeClr val="tx1"/>
+          </a:fontRef>
+        </p:style>
+      </p:cxnSp>
     </p:spTree>
   </p:cSld>
   <p:clrMapOvr>

</xml_diff>